<commit_message>
Harden the plant demo loop and add an illustrated run guide
Stop duplicate and unstaffed missions, lock plant state, draft incomplete
custody certificates, and document how to start the three apps.

Co-authored-by: Cursor <cursoragent@cursor.com>
</commit_message>
<xml_diff>
--- a/docs/pitch/CryoDispatch.pptx
+++ b/docs/pitch/CryoDispatch.pptx
@@ -949,7 +949,7 @@
           <a:p>
             <a:r>
               <a:rPr lang="en-US" dirty="0"/>
-              <a:t/>
+              <a:t>Numbers are from a live run: hold 0.468 kWh vs move 0.220 kWh. Cascade target is FREEZER_BLOOD_06 (ICU satellite 2).</a:t>
             </a:r>
             <a:endParaRPr lang="en-US" dirty="0"/>
           </a:p>
@@ -4110,7 +4110,7 @@
                 <a:ea typeface="Cambria" pitchFamily="34" charset="-122"/>
                 <a:cs typeface="Cambria" pitchFamily="34" charset="-120"/>
               </a:rPr>
-              <a:t>Ninety seconds. A judge holds the phone.</a:t>
+              <a:t>The loop closes on evidence, not an alert</a:t>
             </a:r>
             <a:endParaRPr lang="en-US" sz="2800" dirty="0"/>
           </a:p>
@@ -4125,11 +4125,11 @@
         <p:spPr>
           <a:xfrm>
             <a:off x="548640" y="1143000"/>
-            <a:ext cx="3611880" cy="2240280"/>
+            <a:ext cx="5486400" cy="4937760"/>
           </a:xfrm>
           <a:prstGeom prst="roundRect">
             <a:avLst>
-              <a:gd name="adj" fmla="val 4082"/>
+              <a:gd name="adj" fmla="val 2222"/>
             </a:avLst>
           </a:prstGeom>
           <a:solidFill>
@@ -4140,23 +4140,42 @@
       </p:sp>
       <p:sp>
         <p:nvSpPr>
-          <p:cNvPr id="5" name="Shape 3"/>
-          <p:cNvSpPr/>
-          <p:nvPr/>
-        </p:nvSpPr>
-        <p:spPr>
-          <a:xfrm>
-            <a:off x="777240" y="1417320"/>
-            <a:ext cx="384048" cy="384048"/>
-          </a:xfrm>
-          <a:prstGeom prst="ellipse">
-            <a:avLst/>
-          </a:prstGeom>
-          <a:solidFill>
-            <a:srgbClr val="2EC4B6"/>
-          </a:solidFill>
-          <a:ln/>
-        </p:spPr>
+          <p:cNvPr id="5" name="Text 3"/>
+          <p:cNvSpPr/>
+          <p:nvPr/>
+        </p:nvSpPr>
+        <p:spPr>
+          <a:xfrm>
+            <a:off x="822960" y="1371600"/>
+            <a:ext cx="4937760" cy="457200"/>
+          </a:xfrm>
+          <a:prstGeom prst="rect">
+            <a:avLst/>
+          </a:prstGeom>
+          <a:noFill/>
+          <a:ln/>
+        </p:spPr>
+        <p:txBody>
+          <a:bodyPr wrap="square" lIns="0" tIns="0" rIns="0" bIns="0" rtlCol="0" anchor="ctr"/>
+          <a:lstStyle/>
+          <a:p>
+            <a:pPr indent="0" marL="0">
+              <a:buNone/>
+            </a:pPr>
+            <a:r>
+              <a:rPr lang="en-US" sz="1600" dirty="0">
+                <a:solidFill>
+                  <a:srgbClr val="2EC4B6"/>
+                </a:solidFill>
+                <a:latin typeface="Calibri" pitchFamily="34" charset="0"/>
+                <a:ea typeface="Calibri" pitchFamily="34" charset="-122"/>
+                <a:cs typeface="Calibri" pitchFamily="34" charset="-120"/>
+              </a:rPr>
+              <a:t>Hold the failing vault, or move the stock?</a:t>
+            </a:r>
+            <a:endParaRPr lang="en-US" sz="1600" dirty="0"/>
+          </a:p>
+        </p:txBody>
       </p:sp>
       <p:sp>
         <p:nvSpPr>
@@ -4166,34 +4185,34 @@
         </p:nvSpPr>
         <p:spPr>
           <a:xfrm>
-            <a:off x="777240" y="1417320"/>
-            <a:ext cx="384048" cy="384048"/>
-          </a:xfrm>
-          <a:prstGeom prst="rect">
-            <a:avLst/>
-          </a:prstGeom>
-          <a:noFill/>
-          <a:ln/>
-        </p:spPr>
-        <p:txBody>
-          <a:bodyPr wrap="square" lIns="0" tIns="0" rIns="0" bIns="0" rtlCol="0" anchor="ctr"/>
-          <a:lstStyle/>
-          <a:p>
-            <a:pPr algn="ctr" indent="0" marL="0">
-              <a:buNone/>
-            </a:pPr>
-            <a:r>
-              <a:rPr lang="en-US" sz="1200" b="1" dirty="0">
-                <a:solidFill>
-                  <a:srgbClr val="04151C"/>
-                </a:solidFill>
-                <a:latin typeface="Calibri" pitchFamily="34" charset="0"/>
-                <a:ea typeface="Calibri" pitchFamily="34" charset="-122"/>
-                <a:cs typeface="Calibri" pitchFamily="34" charset="-120"/>
-              </a:rPr>
-              <a:t>1</a:t>
-            </a:r>
-            <a:endParaRPr lang="en-US" sz="1200" dirty="0"/>
+            <a:off x="822960" y="1920240"/>
+            <a:ext cx="2194560" cy="822960"/>
+          </a:xfrm>
+          <a:prstGeom prst="rect">
+            <a:avLst/>
+          </a:prstGeom>
+          <a:noFill/>
+          <a:ln/>
+        </p:spPr>
+        <p:txBody>
+          <a:bodyPr wrap="square" lIns="0" tIns="0" rIns="0" bIns="0" rtlCol="0" anchor="ctr"/>
+          <a:lstStyle/>
+          <a:p>
+            <a:pPr indent="0" marL="0">
+              <a:buNone/>
+            </a:pPr>
+            <a:r>
+              <a:rPr lang="en-US" sz="5400" b="1" dirty="0">
+                <a:solidFill>
+                  <a:srgbClr val="E07A3D"/>
+                </a:solidFill>
+                <a:latin typeface="Calibri" pitchFamily="34" charset="0"/>
+                <a:ea typeface="Calibri" pitchFamily="34" charset="-122"/>
+                <a:cs typeface="Calibri" pitchFamily="34" charset="-120"/>
+              </a:rPr>
+              <a:t>0.468</a:t>
+            </a:r>
+            <a:endParaRPr lang="en-US" sz="5400" dirty="0"/>
           </a:p>
         </p:txBody>
       </p:sp>
@@ -4205,24 +4224,80 @@
         </p:nvSpPr>
         <p:spPr>
           <a:xfrm>
-            <a:off x="1280160" y="1435608"/>
-            <a:ext cx="2560320" cy="365760"/>
-          </a:xfrm>
-          <a:prstGeom prst="rect">
-            <a:avLst/>
-          </a:prstGeom>
-          <a:noFill/>
-          <a:ln/>
-        </p:spPr>
-        <p:txBody>
-          <a:bodyPr wrap="square" lIns="0" tIns="0" rIns="0" bIns="0" rtlCol="0" anchor="ctr"/>
-          <a:lstStyle/>
-          <a:p>
-            <a:pPr indent="0" marL="0">
-              <a:buNone/>
-            </a:pPr>
-            <a:r>
-              <a:rPr lang="en-US" sz="1400" dirty="0">
+            <a:off x="822960" y="2788920"/>
+            <a:ext cx="2194560" cy="731520"/>
+          </a:xfrm>
+          <a:prstGeom prst="rect">
+            <a:avLst/>
+          </a:prstGeom>
+          <a:noFill/>
+          <a:ln/>
+        </p:spPr>
+        <p:txBody>
+          <a:bodyPr wrap="square" lIns="0" tIns="0" rIns="0" bIns="0" rtlCol="0" anchor="ctr"/>
+          <a:lstStyle/>
+          <a:p>
+            <a:pPr indent="0" marL="0">
+              <a:buNone/>
+            </a:pPr>
+            <a:r>
+              <a:rPr lang="en-US" sz="1300" dirty="0">
+                <a:solidFill>
+                  <a:srgbClr val="7FA3AD"/>
+                </a:solidFill>
+                <a:latin typeface="Calibri" pitchFamily="34" charset="0"/>
+                <a:ea typeface="Calibri" pitchFamily="34" charset="-122"/>
+                <a:cs typeface="Calibri" pitchFamily="34" charset="-120"/>
+              </a:rPr>
+              <a:t>kWh to hold a degraded</a:t>
+            </a:r>
+            <a:endParaRPr lang="en-US" sz="1300" dirty="0"/>
+          </a:p>
+          <a:p>
+            <a:pPr indent="0" marL="0">
+              <a:buNone/>
+            </a:pPr>
+            <a:r>
+              <a:rPr lang="en-US" sz="1300" dirty="0">
+                <a:solidFill>
+                  <a:srgbClr val="7FA3AD"/>
+                </a:solidFill>
+                <a:latin typeface="Calibri" pitchFamily="34" charset="0"/>
+                <a:ea typeface="Calibri" pitchFamily="34" charset="-122"/>
+                <a:cs typeface="Calibri" pitchFamily="34" charset="-120"/>
+              </a:rPr>
+              <a:t>compressor for 30 min</a:t>
+            </a:r>
+            <a:endParaRPr lang="en-US" sz="1300" dirty="0"/>
+          </a:p>
+        </p:txBody>
+      </p:sp>
+      <p:sp>
+        <p:nvSpPr>
+          <p:cNvPr id="8" name="Text 6"/>
+          <p:cNvSpPr/>
+          <p:nvPr/>
+        </p:nvSpPr>
+        <p:spPr>
+          <a:xfrm>
+            <a:off x="3383280" y="1920240"/>
+            <a:ext cx="2194560" cy="822960"/>
+          </a:xfrm>
+          <a:prstGeom prst="rect">
+            <a:avLst/>
+          </a:prstGeom>
+          <a:noFill/>
+          <a:ln/>
+        </p:spPr>
+        <p:txBody>
+          <a:bodyPr wrap="square" lIns="0" tIns="0" rIns="0" bIns="0" rtlCol="0" anchor="ctr"/>
+          <a:lstStyle/>
+          <a:p>
+            <a:pPr indent="0" marL="0">
+              <a:buNone/>
+            </a:pPr>
+            <a:r>
+              <a:rPr lang="en-US" sz="5400" b="1" dirty="0">
                 <a:solidFill>
                   <a:srgbClr val="2EC4B6"/>
                 </a:solidFill>
@@ -4230,38 +4305,94 @@
                 <a:ea typeface="Calibri" pitchFamily="34" charset="-122"/>
                 <a:cs typeface="Calibri" pitchFamily="34" charset="-120"/>
               </a:rPr>
-              <a:t>0–10s</a:t>
-            </a:r>
-            <a:endParaRPr lang="en-US" sz="1400" dirty="0"/>
-          </a:p>
-        </p:txBody>
-      </p:sp>
-      <p:sp>
-        <p:nvSpPr>
-          <p:cNvPr id="8" name="Text 6"/>
-          <p:cNvSpPr/>
-          <p:nvPr/>
-        </p:nvSpPr>
-        <p:spPr>
-          <a:xfrm>
-            <a:off x="777240" y="2057400"/>
-            <a:ext cx="3154680" cy="1005840"/>
-          </a:xfrm>
-          <a:prstGeom prst="rect">
-            <a:avLst/>
-          </a:prstGeom>
-          <a:noFill/>
-          <a:ln/>
-        </p:spPr>
-        <p:txBody>
-          <a:bodyPr wrap="square" lIns="0" tIns="0" rIns="0" bIns="0" rtlCol="0" anchor="ctr"/>
-          <a:lstStyle/>
-          <a:p>
-            <a:pPr indent="0" marL="0">
-              <a:buNone/>
-            </a:pPr>
-            <a:r>
-              <a:rPr lang="en-US" sz="1600" dirty="0">
+              <a:t>0.220</a:t>
+            </a:r>
+            <a:endParaRPr lang="en-US" sz="5400" dirty="0"/>
+          </a:p>
+        </p:txBody>
+      </p:sp>
+      <p:sp>
+        <p:nvSpPr>
+          <p:cNvPr id="9" name="Text 7"/>
+          <p:cNvSpPr/>
+          <p:nvPr/>
+        </p:nvSpPr>
+        <p:spPr>
+          <a:xfrm>
+            <a:off x="3383280" y="2788920"/>
+            <a:ext cx="2194560" cy="731520"/>
+          </a:xfrm>
+          <a:prstGeom prst="rect">
+            <a:avLst/>
+          </a:prstGeom>
+          <a:noFill/>
+          <a:ln/>
+        </p:spPr>
+        <p:txBody>
+          <a:bodyPr wrap="square" lIns="0" tIns="0" rIns="0" bIns="0" rtlCol="0" anchor="ctr"/>
+          <a:lstStyle/>
+          <a:p>
+            <a:pPr indent="0" marL="0">
+              <a:buNone/>
+            </a:pPr>
+            <a:r>
+              <a:rPr lang="en-US" sz="1300" dirty="0">
+                <a:solidFill>
+                  <a:srgbClr val="7FA3AD"/>
+                </a:solidFill>
+                <a:latin typeface="Calibri" pitchFamily="34" charset="0"/>
+                <a:ea typeface="Calibri" pitchFamily="34" charset="-122"/>
+                <a:cs typeface="Calibri" pitchFamily="34" charset="-120"/>
+              </a:rPr>
+              <a:t>kWh to relocate the</a:t>
+            </a:r>
+            <a:endParaRPr lang="en-US" sz="1300" dirty="0"/>
+          </a:p>
+          <a:p>
+            <a:pPr indent="0" marL="0">
+              <a:buNone/>
+            </a:pPr>
+            <a:r>
+              <a:rPr lang="en-US" sz="1300" dirty="0">
+                <a:solidFill>
+                  <a:srgbClr val="7FA3AD"/>
+                </a:solidFill>
+                <a:latin typeface="Calibri" pitchFamily="34" charset="0"/>
+                <a:ea typeface="Calibri" pitchFamily="34" charset="-122"/>
+                <a:cs typeface="Calibri" pitchFamily="34" charset="-120"/>
+              </a:rPr>
+              <a:t>stock and let it cool</a:t>
+            </a:r>
+            <a:endParaRPr lang="en-US" sz="1300" dirty="0"/>
+          </a:p>
+        </p:txBody>
+      </p:sp>
+      <p:sp>
+        <p:nvSpPr>
+          <p:cNvPr id="10" name="Text 8"/>
+          <p:cNvSpPr/>
+          <p:nvPr/>
+        </p:nvSpPr>
+        <p:spPr>
+          <a:xfrm>
+            <a:off x="822960" y="3749040"/>
+            <a:ext cx="4937760" cy="1920240"/>
+          </a:xfrm>
+          <a:prstGeom prst="rect">
+            <a:avLst/>
+          </a:prstGeom>
+          <a:noFill/>
+          <a:ln/>
+        </p:spPr>
+        <p:txBody>
+          <a:bodyPr wrap="square" lIns="0" tIns="0" rIns="0" bIns="0" rtlCol="0" anchor="ctr"/>
+          <a:lstStyle/>
+          <a:p>
+            <a:pPr indent="0" marL="0">
+              <a:buNone/>
+            </a:pPr>
+            <a:r>
+              <a:rPr lang="en-US" sz="1500" dirty="0">
                 <a:solidFill>
                   <a:srgbClr val="E8F1F2"/>
                 </a:solidFill>
@@ -4269,103 +4400,207 @@
                 <a:ea typeface="Calibri" pitchFamily="34" charset="-122"/>
                 <a:cs typeface="Calibri" pitchFamily="34" charset="-120"/>
               </a:rPr>
-              <a:t>Plant, not a chart</a:t>
-            </a:r>
-            <a:endParaRPr lang="en-US" sz="1600" dirty="0"/>
-          </a:p>
-        </p:txBody>
-      </p:sp>
-      <p:sp>
-        <p:nvSpPr>
-          <p:cNvPr id="9" name="Shape 7"/>
-          <p:cNvSpPr/>
-          <p:nvPr/>
-        </p:nvSpPr>
-        <p:spPr>
-          <a:xfrm>
-            <a:off x="4343400" y="1143000"/>
-            <a:ext cx="3611880" cy="2240280"/>
+              <a:t>The router also refuses a backup that could not absorb a second failure. Vault 3 had room for one vault, not two — so the next failure cascaded to ICU satellite 2 before anyone asked.</a:t>
+            </a:r>
+            <a:endParaRPr lang="en-US" sz="1500" dirty="0"/>
+          </a:p>
+        </p:txBody>
+      </p:sp>
+      <p:sp>
+        <p:nvSpPr>
+          <p:cNvPr id="11" name="Shape 9"/>
+          <p:cNvSpPr/>
+          <p:nvPr/>
+        </p:nvSpPr>
+        <p:spPr>
+          <a:xfrm>
+            <a:off x="6309360" y="1143000"/>
+            <a:ext cx="5303520" cy="4937760"/>
           </a:xfrm>
           <a:prstGeom prst="roundRect">
             <a:avLst>
-              <a:gd name="adj" fmla="val 4082"/>
+              <a:gd name="adj" fmla="val 2222"/>
             </a:avLst>
           </a:prstGeom>
           <a:solidFill>
-            <a:srgbClr val="0B2430"/>
+            <a:srgbClr val="04151C"/>
           </a:solidFill>
           <a:ln/>
         </p:spPr>
       </p:sp>
       <p:sp>
         <p:nvSpPr>
-          <p:cNvPr id="10" name="Shape 8"/>
-          <p:cNvSpPr/>
-          <p:nvPr/>
-        </p:nvSpPr>
-        <p:spPr>
-          <a:xfrm>
-            <a:off x="4572000" y="1417320"/>
-            <a:ext cx="384048" cy="384048"/>
-          </a:xfrm>
-          <a:prstGeom prst="ellipse">
-            <a:avLst/>
-          </a:prstGeom>
-          <a:solidFill>
-            <a:srgbClr val="2EC4B6"/>
-          </a:solidFill>
-          <a:ln/>
-        </p:spPr>
-      </p:sp>
-      <p:sp>
-        <p:nvSpPr>
-          <p:cNvPr id="11" name="Text 9"/>
-          <p:cNvSpPr/>
-          <p:nvPr/>
-        </p:nvSpPr>
-        <p:spPr>
-          <a:xfrm>
-            <a:off x="4572000" y="1417320"/>
-            <a:ext cx="384048" cy="384048"/>
-          </a:xfrm>
-          <a:prstGeom prst="rect">
-            <a:avLst/>
-          </a:prstGeom>
-          <a:noFill/>
-          <a:ln/>
-        </p:spPr>
-        <p:txBody>
-          <a:bodyPr wrap="square" lIns="0" tIns="0" rIns="0" bIns="0" rtlCol="0" anchor="ctr"/>
-          <a:lstStyle/>
-          <a:p>
-            <a:pPr algn="ctr" indent="0" marL="0">
-              <a:buNone/>
-            </a:pPr>
-            <a:r>
-              <a:rPr lang="en-US" sz="1200" b="1" dirty="0">
-                <a:solidFill>
-                  <a:srgbClr val="04151C"/>
-                </a:solidFill>
-                <a:latin typeface="Calibri" pitchFamily="34" charset="0"/>
-                <a:ea typeface="Calibri" pitchFamily="34" charset="-122"/>
-                <a:cs typeface="Calibri" pitchFamily="34" charset="-120"/>
-              </a:rPr>
-              <a:t>2</a:t>
-            </a:r>
-            <a:endParaRPr lang="en-US" sz="1200" dirty="0"/>
-          </a:p>
-        </p:txBody>
-      </p:sp>
-      <p:sp>
-        <p:nvSpPr>
           <p:cNvPr id="12" name="Text 10"/>
           <p:cNvSpPr/>
           <p:nvPr/>
         </p:nvSpPr>
         <p:spPr>
           <a:xfrm>
-            <a:off x="5074920" y="1435608"/>
-            <a:ext cx="2560320" cy="365760"/>
+            <a:off x="6583680" y="1371600"/>
+            <a:ext cx="4754880" cy="365760"/>
+          </a:xfrm>
+          <a:prstGeom prst="rect">
+            <a:avLst/>
+          </a:prstGeom>
+          <a:noFill/>
+          <a:ln/>
+        </p:spPr>
+        <p:txBody>
+          <a:bodyPr wrap="square" lIns="0" tIns="0" rIns="0" bIns="0" rtlCol="0" anchor="ctr"/>
+          <a:lstStyle/>
+          <a:p>
+            <a:pPr indent="0" marL="0">
+              <a:buNone/>
+            </a:pPr>
+            <a:r>
+              <a:rPr lang="en-US" sz="1600" dirty="0">
+                <a:solidFill>
+                  <a:srgbClr val="2EC4B6"/>
+                </a:solidFill>
+                <a:latin typeface="Calibri" pitchFamily="34" charset="0"/>
+                <a:ea typeface="Calibri" pitchFamily="34" charset="-122"/>
+                <a:cs typeface="Calibri" pitchFamily="34" charset="-120"/>
+              </a:rPr>
+              <a:t>Chain of Cold Custody</a:t>
+            </a:r>
+            <a:endParaRPr lang="en-US" sz="1600" dirty="0"/>
+          </a:p>
+        </p:txBody>
+      </p:sp>
+      <p:sp>
+        <p:nvSpPr>
+          <p:cNvPr id="13" name="Text 11"/>
+          <p:cNvSpPr/>
+          <p:nvPr/>
+        </p:nvSpPr>
+        <p:spPr>
+          <a:xfrm>
+            <a:off x="6583680" y="1920240"/>
+            <a:ext cx="4754880" cy="2743200"/>
+          </a:xfrm>
+          <a:prstGeom prst="rect">
+            <a:avLst/>
+          </a:prstGeom>
+          <a:noFill/>
+          <a:ln/>
+        </p:spPr>
+        <p:txBody>
+          <a:bodyPr wrap="square" lIns="0" tIns="0" rIns="0" bIns="0" rtlCol="0" anchor="ctr"/>
+          <a:lstStyle/>
+          <a:p>
+            <a:pPr indent="0" marL="0">
+              <a:buNone/>
+            </a:pPr>
+            <a:r>
+              <a:rPr lang="en-US" sz="1600" dirty="0">
+                <a:solidFill>
+                  <a:srgbClr val="E8F1F2"/>
+                </a:solidFill>
+                <a:latin typeface="Calibri" pitchFamily="34" charset="0"/>
+                <a:ea typeface="Calibri" pitchFamily="34" charset="-122"/>
+                <a:cs typeface="Calibri" pitchFamily="34" charset="-120"/>
+              </a:rPr>
+              <a:t>Every handoff, timestamped IST</a:t>
+            </a:r>
+            <a:endParaRPr lang="en-US" sz="1600" dirty="0"/>
+          </a:p>
+          <a:p>
+            <a:pPr indent="0" marL="0">
+              <a:buNone/>
+            </a:pPr>
+            <a:r>
+              <a:rPr lang="en-US" sz="1600" dirty="0">
+                <a:solidFill>
+                  <a:srgbClr val="E8F1F2"/>
+                </a:solidFill>
+                <a:latin typeface="Calibri" pitchFamily="34" charset="0"/>
+                <a:ea typeface="Calibri" pitchFamily="34" charset="-122"/>
+                <a:cs typeface="Calibri" pitchFamily="34" charset="-120"/>
+              </a:rPr>
+              <a:t>Min / max / time out of range</a:t>
+            </a:r>
+            <a:endParaRPr lang="en-US" sz="1600" dirty="0"/>
+          </a:p>
+          <a:p>
+            <a:pPr indent="0" marL="0">
+              <a:buNone/>
+            </a:pPr>
+            <a:r>
+              <a:rPr lang="en-US" sz="1600" dirty="0">
+                <a:solidFill>
+                  <a:srgbClr val="E8F1F2"/>
+                </a:solidFill>
+                <a:latin typeface="Calibri" pitchFamily="34" charset="0"/>
+                <a:ea typeface="Calibri" pitchFamily="34" charset="-122"/>
+                <a:cs typeface="Calibri" pitchFamily="34" charset="-120"/>
+              </a:rPr>
+              <a:t>Sensor ID + last calibration</a:t>
+            </a:r>
+            <a:endParaRPr lang="en-US" sz="1600" dirty="0"/>
+          </a:p>
+          <a:p>
+            <a:pPr indent="0" marL="0">
+              <a:buNone/>
+            </a:pPr>
+            <a:r>
+              <a:rPr lang="en-US" sz="1600" dirty="0">
+                <a:solidFill>
+                  <a:srgbClr val="E8F1F2"/>
+                </a:solidFill>
+                <a:latin typeface="Calibri" pitchFamily="34" charset="0"/>
+                <a:ea typeface="Calibri" pitchFamily="34" charset="-122"/>
+                <a:cs typeface="Calibri" pitchFamily="34" charset="-120"/>
+              </a:rPr>
+              <a:t>Disposition: released or quarantined</a:t>
+            </a:r>
+            <a:endParaRPr lang="en-US" sz="1600" dirty="0"/>
+          </a:p>
+          <a:p>
+            <a:pPr indent="0" marL="0">
+              <a:buNone/>
+            </a:pPr>
+            <a:r>
+              <a:rPr lang="en-US" sz="1600" dirty="0">
+                <a:solidFill>
+                  <a:srgbClr val="E8F1F2"/>
+                </a:solidFill>
+                <a:latin typeface="Calibri" pitchFamily="34" charset="0"/>
+                <a:ea typeface="Calibri" pitchFamily="34" charset="-122"/>
+                <a:cs typeface="Calibri" pitchFamily="34" charset="-120"/>
+              </a:rPr>
+              <a:t>Computer-generated audit trail</a:t>
+            </a:r>
+            <a:endParaRPr lang="en-US" sz="1600" dirty="0"/>
+          </a:p>
+          <a:p>
+            <a:pPr indent="0" marL="0">
+              <a:buNone/>
+            </a:pPr>
+            <a:r>
+              <a:rPr lang="en-US" sz="1600" dirty="0">
+                <a:solidFill>
+                  <a:srgbClr val="E8F1F2"/>
+                </a:solidFill>
+                <a:latin typeface="Calibri" pitchFamily="34" charset="0"/>
+                <a:ea typeface="Calibri" pitchFamily="34" charset="-122"/>
+                <a:cs typeface="Calibri" pitchFamily="34" charset="-120"/>
+              </a:rPr>
+              <a:t>Payload hash on every document</a:t>
+            </a:r>
+            <a:endParaRPr lang="en-US" sz="1600" dirty="0"/>
+          </a:p>
+        </p:txBody>
+      </p:sp>
+      <p:sp>
+        <p:nvSpPr>
+          <p:cNvPr id="14" name="Text 12"/>
+          <p:cNvSpPr/>
+          <p:nvPr/>
+        </p:nvSpPr>
+        <p:spPr>
+          <a:xfrm>
+            <a:off x="6583680" y="4846320"/>
+            <a:ext cx="4754880" cy="914400"/>
           </a:xfrm>
           <a:prstGeom prst="rect">
             <a:avLst/>
@@ -4383,690 +4618,15 @@
             <a:r>
               <a:rPr lang="en-US" sz="1400" dirty="0">
                 <a:solidFill>
-                  <a:srgbClr val="2EC4B6"/>
-                </a:solidFill>
-                <a:latin typeface="Calibri" pitchFamily="34" charset="0"/>
-                <a:ea typeface="Calibri" pitchFamily="34" charset="-122"/>
-                <a:cs typeface="Calibri" pitchFamily="34" charset="-120"/>
-              </a:rPr>
-              <a:t>10–25s</a:t>
+                  <a:srgbClr val="7FA3AD"/>
+                </a:solidFill>
+                <a:latin typeface="Calibri" pitchFamily="34" charset="0"/>
+                <a:ea typeface="Calibri" pitchFamily="34" charset="-122"/>
+                <a:cs typeface="Calibri" pitchFamily="34" charset="-120"/>
+              </a:rPr>
+              <a:t>We moved before any excursion, so this batch reads RELEASED — and the document proves it.</a:t>
             </a:r>
             <a:endParaRPr lang="en-US" sz="1400" dirty="0"/>
-          </a:p>
-        </p:txBody>
-      </p:sp>
-      <p:sp>
-        <p:nvSpPr>
-          <p:cNvPr id="13" name="Text 11"/>
-          <p:cNvSpPr/>
-          <p:nvPr/>
-        </p:nvSpPr>
-        <p:spPr>
-          <a:xfrm>
-            <a:off x="4572000" y="2057400"/>
-            <a:ext cx="3154680" cy="1005840"/>
-          </a:xfrm>
-          <a:prstGeom prst="rect">
-            <a:avLst/>
-          </a:prstGeom>
-          <a:noFill/>
-          <a:ln/>
-        </p:spPr>
-        <p:txBody>
-          <a:bodyPr wrap="square" lIns="0" tIns="0" rIns="0" bIns="0" rtlCol="0" anchor="ctr"/>
-          <a:lstStyle/>
-          <a:p>
-            <a:pPr indent="0" marL="0">
-              <a:buNone/>
-            </a:pPr>
-            <a:r>
-              <a:rPr lang="en-US" sz="1600" dirty="0">
-                <a:solidFill>
-                  <a:srgbClr val="E8F1F2"/>
-                </a:solidFill>
-                <a:latin typeface="Calibri" pitchFamily="34" charset="0"/>
-                <a:ea typeface="Calibri" pitchFamily="34" charset="-122"/>
-                <a:cs typeface="Calibri" pitchFamily="34" charset="-120"/>
-              </a:rPr>
-              <a:t>Kill probe → ticket, no MOVE</a:t>
-            </a:r>
-            <a:endParaRPr lang="en-US" sz="1600" dirty="0"/>
-          </a:p>
-        </p:txBody>
-      </p:sp>
-      <p:sp>
-        <p:nvSpPr>
-          <p:cNvPr id="14" name="Shape 12"/>
-          <p:cNvSpPr/>
-          <p:nvPr/>
-        </p:nvSpPr>
-        <p:spPr>
-          <a:xfrm>
-            <a:off x="8138160" y="1143000"/>
-            <a:ext cx="3611880" cy="2240280"/>
-          </a:xfrm>
-          <a:prstGeom prst="roundRect">
-            <a:avLst>
-              <a:gd name="adj" fmla="val 4082"/>
-            </a:avLst>
-          </a:prstGeom>
-          <a:solidFill>
-            <a:srgbClr val="0B2430"/>
-          </a:solidFill>
-          <a:ln/>
-        </p:spPr>
-      </p:sp>
-      <p:sp>
-        <p:nvSpPr>
-          <p:cNvPr id="15" name="Shape 13"/>
-          <p:cNvSpPr/>
-          <p:nvPr/>
-        </p:nvSpPr>
-        <p:spPr>
-          <a:xfrm>
-            <a:off x="8366760" y="1417320"/>
-            <a:ext cx="384048" cy="384048"/>
-          </a:xfrm>
-          <a:prstGeom prst="ellipse">
-            <a:avLst/>
-          </a:prstGeom>
-          <a:solidFill>
-            <a:srgbClr val="2EC4B6"/>
-          </a:solidFill>
-          <a:ln/>
-        </p:spPr>
-      </p:sp>
-      <p:sp>
-        <p:nvSpPr>
-          <p:cNvPr id="16" name="Text 14"/>
-          <p:cNvSpPr/>
-          <p:nvPr/>
-        </p:nvSpPr>
-        <p:spPr>
-          <a:xfrm>
-            <a:off x="8366760" y="1417320"/>
-            <a:ext cx="384048" cy="384048"/>
-          </a:xfrm>
-          <a:prstGeom prst="rect">
-            <a:avLst/>
-          </a:prstGeom>
-          <a:noFill/>
-          <a:ln/>
-        </p:spPr>
-        <p:txBody>
-          <a:bodyPr wrap="square" lIns="0" tIns="0" rIns="0" bIns="0" rtlCol="0" anchor="ctr"/>
-          <a:lstStyle/>
-          <a:p>
-            <a:pPr algn="ctr" indent="0" marL="0">
-              <a:buNone/>
-            </a:pPr>
-            <a:r>
-              <a:rPr lang="en-US" sz="1200" b="1" dirty="0">
-                <a:solidFill>
-                  <a:srgbClr val="04151C"/>
-                </a:solidFill>
-                <a:latin typeface="Calibri" pitchFamily="34" charset="0"/>
-                <a:ea typeface="Calibri" pitchFamily="34" charset="-122"/>
-                <a:cs typeface="Calibri" pitchFamily="34" charset="-120"/>
-              </a:rPr>
-              <a:t>3</a:t>
-            </a:r>
-            <a:endParaRPr lang="en-US" sz="1200" dirty="0"/>
-          </a:p>
-        </p:txBody>
-      </p:sp>
-      <p:sp>
-        <p:nvSpPr>
-          <p:cNvPr id="17" name="Text 15"/>
-          <p:cNvSpPr/>
-          <p:nvPr/>
-        </p:nvSpPr>
-        <p:spPr>
-          <a:xfrm>
-            <a:off x="8869680" y="1435608"/>
-            <a:ext cx="2560320" cy="365760"/>
-          </a:xfrm>
-          <a:prstGeom prst="rect">
-            <a:avLst/>
-          </a:prstGeom>
-          <a:noFill/>
-          <a:ln/>
-        </p:spPr>
-        <p:txBody>
-          <a:bodyPr wrap="square" lIns="0" tIns="0" rIns="0" bIns="0" rtlCol="0" anchor="ctr"/>
-          <a:lstStyle/>
-          <a:p>
-            <a:pPr indent="0" marL="0">
-              <a:buNone/>
-            </a:pPr>
-            <a:r>
-              <a:rPr lang="en-US" sz="1400" dirty="0">
-                <a:solidFill>
-                  <a:srgbClr val="2EC4B6"/>
-                </a:solidFill>
-                <a:latin typeface="Calibri" pitchFamily="34" charset="0"/>
-                <a:ea typeface="Calibri" pitchFamily="34" charset="-122"/>
-                <a:cs typeface="Calibri" pitchFamily="34" charset="-120"/>
-              </a:rPr>
-              <a:t>25–40s</a:t>
-            </a:r>
-            <a:endParaRPr lang="en-US" sz="1400" dirty="0"/>
-          </a:p>
-        </p:txBody>
-      </p:sp>
-      <p:sp>
-        <p:nvSpPr>
-          <p:cNvPr id="18" name="Text 16"/>
-          <p:cNvSpPr/>
-          <p:nvPr/>
-        </p:nvSpPr>
-        <p:spPr>
-          <a:xfrm>
-            <a:off x="8366760" y="2057400"/>
-            <a:ext cx="3154680" cy="1005840"/>
-          </a:xfrm>
-          <a:prstGeom prst="rect">
-            <a:avLst/>
-          </a:prstGeom>
-          <a:noFill/>
-          <a:ln/>
-        </p:spPr>
-        <p:txBody>
-          <a:bodyPr wrap="square" lIns="0" tIns="0" rIns="0" bIns="0" rtlCol="0" anchor="ctr"/>
-          <a:lstStyle/>
-          <a:p>
-            <a:pPr indent="0" marL="0">
-              <a:buNone/>
-            </a:pPr>
-            <a:r>
-              <a:rPr lang="en-US" sz="1600" dirty="0">
-                <a:solidFill>
-                  <a:srgbClr val="E8F1F2"/>
-                </a:solidFill>
-                <a:latin typeface="Calibri" pitchFamily="34" charset="0"/>
-                <a:ea typeface="Calibri" pitchFamily="34" charset="-122"/>
-                <a:cs typeface="Calibri" pitchFamily="34" charset="-120"/>
-              </a:rPr>
-              <a:t>Compressor: T_eq up, air still legal</a:t>
-            </a:r>
-            <a:endParaRPr lang="en-US" sz="1600" dirty="0"/>
-          </a:p>
-        </p:txBody>
-      </p:sp>
-      <p:sp>
-        <p:nvSpPr>
-          <p:cNvPr id="19" name="Shape 17"/>
-          <p:cNvSpPr/>
-          <p:nvPr/>
-        </p:nvSpPr>
-        <p:spPr>
-          <a:xfrm>
-            <a:off x="548640" y="3611880"/>
-            <a:ext cx="3611880" cy="2240280"/>
-          </a:xfrm>
-          <a:prstGeom prst="roundRect">
-            <a:avLst>
-              <a:gd name="adj" fmla="val 4082"/>
-            </a:avLst>
-          </a:prstGeom>
-          <a:solidFill>
-            <a:srgbClr val="0B2430"/>
-          </a:solidFill>
-          <a:ln/>
-        </p:spPr>
-      </p:sp>
-      <p:sp>
-        <p:nvSpPr>
-          <p:cNvPr id="20" name="Shape 18"/>
-          <p:cNvSpPr/>
-          <p:nvPr/>
-        </p:nvSpPr>
-        <p:spPr>
-          <a:xfrm>
-            <a:off x="777240" y="3886200"/>
-            <a:ext cx="384048" cy="384048"/>
-          </a:xfrm>
-          <a:prstGeom prst="ellipse">
-            <a:avLst/>
-          </a:prstGeom>
-          <a:solidFill>
-            <a:srgbClr val="2EC4B6"/>
-          </a:solidFill>
-          <a:ln/>
-        </p:spPr>
-      </p:sp>
-      <p:sp>
-        <p:nvSpPr>
-          <p:cNvPr id="21" name="Text 19"/>
-          <p:cNvSpPr/>
-          <p:nvPr/>
-        </p:nvSpPr>
-        <p:spPr>
-          <a:xfrm>
-            <a:off x="777240" y="3886200"/>
-            <a:ext cx="384048" cy="384048"/>
-          </a:xfrm>
-          <a:prstGeom prst="rect">
-            <a:avLst/>
-          </a:prstGeom>
-          <a:noFill/>
-          <a:ln/>
-        </p:spPr>
-        <p:txBody>
-          <a:bodyPr wrap="square" lIns="0" tIns="0" rIns="0" bIns="0" rtlCol="0" anchor="ctr"/>
-          <a:lstStyle/>
-          <a:p>
-            <a:pPr algn="ctr" indent="0" marL="0">
-              <a:buNone/>
-            </a:pPr>
-            <a:r>
-              <a:rPr lang="en-US" sz="1200" b="1" dirty="0">
-                <a:solidFill>
-                  <a:srgbClr val="04151C"/>
-                </a:solidFill>
-                <a:latin typeface="Calibri" pitchFamily="34" charset="0"/>
-                <a:ea typeface="Calibri" pitchFamily="34" charset="-122"/>
-                <a:cs typeface="Calibri" pitchFamily="34" charset="-120"/>
-              </a:rPr>
-              <a:t>4</a:t>
-            </a:r>
-            <a:endParaRPr lang="en-US" sz="1200" dirty="0"/>
-          </a:p>
-        </p:txBody>
-      </p:sp>
-      <p:sp>
-        <p:nvSpPr>
-          <p:cNvPr id="22" name="Text 20"/>
-          <p:cNvSpPr/>
-          <p:nvPr/>
-        </p:nvSpPr>
-        <p:spPr>
-          <a:xfrm>
-            <a:off x="1280160" y="3904488"/>
-            <a:ext cx="2560320" cy="365760"/>
-          </a:xfrm>
-          <a:prstGeom prst="rect">
-            <a:avLst/>
-          </a:prstGeom>
-          <a:noFill/>
-          <a:ln/>
-        </p:spPr>
-        <p:txBody>
-          <a:bodyPr wrap="square" lIns="0" tIns="0" rIns="0" bIns="0" rtlCol="0" anchor="ctr"/>
-          <a:lstStyle/>
-          <a:p>
-            <a:pPr indent="0" marL="0">
-              <a:buNone/>
-            </a:pPr>
-            <a:r>
-              <a:rPr lang="en-US" sz="1400" dirty="0">
-                <a:solidFill>
-                  <a:srgbClr val="2EC4B6"/>
-                </a:solidFill>
-                <a:latin typeface="Calibri" pitchFamily="34" charset="0"/>
-                <a:ea typeface="Calibri" pitchFamily="34" charset="-122"/>
-                <a:cs typeface="Calibri" pitchFamily="34" charset="-120"/>
-              </a:rPr>
-              <a:t>40–65s</a:t>
-            </a:r>
-            <a:endParaRPr lang="en-US" sz="1400" dirty="0"/>
-          </a:p>
-        </p:txBody>
-      </p:sp>
-      <p:sp>
-        <p:nvSpPr>
-          <p:cNvPr id="23" name="Text 21"/>
-          <p:cNvSpPr/>
-          <p:nvPr/>
-        </p:nvSpPr>
-        <p:spPr>
-          <a:xfrm>
-            <a:off x="777240" y="4526280"/>
-            <a:ext cx="3154680" cy="1005840"/>
-          </a:xfrm>
-          <a:prstGeom prst="rect">
-            <a:avLst/>
-          </a:prstGeom>
-          <a:noFill/>
-          <a:ln/>
-        </p:spPr>
-        <p:txBody>
-          <a:bodyPr wrap="square" lIns="0" tIns="0" rIns="0" bIns="0" rtlCol="0" anchor="ctr"/>
-          <a:lstStyle/>
-          <a:p>
-            <a:pPr indent="0" marL="0">
-              <a:buNone/>
-            </a:pPr>
-            <a:r>
-              <a:rPr lang="en-US" sz="1600" dirty="0">
-                <a:solidFill>
-                  <a:srgbClr val="E8F1F2"/>
-                </a:solidFill>
-                <a:latin typeface="Calibri" pitchFamily="34" charset="0"/>
-                <a:ea typeface="Calibri" pitchFamily="34" charset="-122"/>
-                <a:cs typeface="Calibri" pitchFamily="34" charset="-120"/>
-              </a:rPr>
-              <a:t>Accept. Wrong-vault QR fails.</a:t>
-            </a:r>
-            <a:endParaRPr lang="en-US" sz="1600" dirty="0"/>
-          </a:p>
-        </p:txBody>
-      </p:sp>
-      <p:sp>
-        <p:nvSpPr>
-          <p:cNvPr id="24" name="Shape 22"/>
-          <p:cNvSpPr/>
-          <p:nvPr/>
-        </p:nvSpPr>
-        <p:spPr>
-          <a:xfrm>
-            <a:off x="4343400" y="3611880"/>
-            <a:ext cx="3611880" cy="2240280"/>
-          </a:xfrm>
-          <a:prstGeom prst="roundRect">
-            <a:avLst>
-              <a:gd name="adj" fmla="val 4082"/>
-            </a:avLst>
-          </a:prstGeom>
-          <a:solidFill>
-            <a:srgbClr val="0B2430"/>
-          </a:solidFill>
-          <a:ln/>
-        </p:spPr>
-      </p:sp>
-      <p:sp>
-        <p:nvSpPr>
-          <p:cNvPr id="25" name="Shape 23"/>
-          <p:cNvSpPr/>
-          <p:nvPr/>
-        </p:nvSpPr>
-        <p:spPr>
-          <a:xfrm>
-            <a:off x="4572000" y="3886200"/>
-            <a:ext cx="384048" cy="384048"/>
-          </a:xfrm>
-          <a:prstGeom prst="ellipse">
-            <a:avLst/>
-          </a:prstGeom>
-          <a:solidFill>
-            <a:srgbClr val="2EC4B6"/>
-          </a:solidFill>
-          <a:ln/>
-        </p:spPr>
-      </p:sp>
-      <p:sp>
-        <p:nvSpPr>
-          <p:cNvPr id="26" name="Text 24"/>
-          <p:cNvSpPr/>
-          <p:nvPr/>
-        </p:nvSpPr>
-        <p:spPr>
-          <a:xfrm>
-            <a:off x="4572000" y="3886200"/>
-            <a:ext cx="384048" cy="384048"/>
-          </a:xfrm>
-          <a:prstGeom prst="rect">
-            <a:avLst/>
-          </a:prstGeom>
-          <a:noFill/>
-          <a:ln/>
-        </p:spPr>
-        <p:txBody>
-          <a:bodyPr wrap="square" lIns="0" tIns="0" rIns="0" bIns="0" rtlCol="0" anchor="ctr"/>
-          <a:lstStyle/>
-          <a:p>
-            <a:pPr algn="ctr" indent="0" marL="0">
-              <a:buNone/>
-            </a:pPr>
-            <a:r>
-              <a:rPr lang="en-US" sz="1200" b="1" dirty="0">
-                <a:solidFill>
-                  <a:srgbClr val="04151C"/>
-                </a:solidFill>
-                <a:latin typeface="Calibri" pitchFamily="34" charset="0"/>
-                <a:ea typeface="Calibri" pitchFamily="34" charset="-122"/>
-                <a:cs typeface="Calibri" pitchFamily="34" charset="-120"/>
-              </a:rPr>
-              <a:t>5</a:t>
-            </a:r>
-            <a:endParaRPr lang="en-US" sz="1200" dirty="0"/>
-          </a:p>
-        </p:txBody>
-      </p:sp>
-      <p:sp>
-        <p:nvSpPr>
-          <p:cNvPr id="27" name="Text 25"/>
-          <p:cNvSpPr/>
-          <p:nvPr/>
-        </p:nvSpPr>
-        <p:spPr>
-          <a:xfrm>
-            <a:off x="5074920" y="3904488"/>
-            <a:ext cx="2560320" cy="365760"/>
-          </a:xfrm>
-          <a:prstGeom prst="rect">
-            <a:avLst/>
-          </a:prstGeom>
-          <a:noFill/>
-          <a:ln/>
-        </p:spPr>
-        <p:txBody>
-          <a:bodyPr wrap="square" lIns="0" tIns="0" rIns="0" bIns="0" rtlCol="0" anchor="ctr"/>
-          <a:lstStyle/>
-          <a:p>
-            <a:pPr indent="0" marL="0">
-              <a:buNone/>
-            </a:pPr>
-            <a:r>
-              <a:rPr lang="en-US" sz="1400" dirty="0">
-                <a:solidFill>
-                  <a:srgbClr val="2EC4B6"/>
-                </a:solidFill>
-                <a:latin typeface="Calibri" pitchFamily="34" charset="0"/>
-                <a:ea typeface="Calibri" pitchFamily="34" charset="-122"/>
-                <a:cs typeface="Calibri" pitchFamily="34" charset="-120"/>
-              </a:rPr>
-              <a:t>65–80s</a:t>
-            </a:r>
-            <a:endParaRPr lang="en-US" sz="1400" dirty="0"/>
-          </a:p>
-        </p:txBody>
-      </p:sp>
-      <p:sp>
-        <p:nvSpPr>
-          <p:cNvPr id="28" name="Text 26"/>
-          <p:cNvSpPr/>
-          <p:nvPr/>
-        </p:nvSpPr>
-        <p:spPr>
-          <a:xfrm>
-            <a:off x="4572000" y="4526280"/>
-            <a:ext cx="3154680" cy="1005840"/>
-          </a:xfrm>
-          <a:prstGeom prst="rect">
-            <a:avLst/>
-          </a:prstGeom>
-          <a:noFill/>
-          <a:ln/>
-        </p:spPr>
-        <p:txBody>
-          <a:bodyPr wrap="square" lIns="0" tIns="0" rIns="0" bIns="0" rtlCol="0" anchor="ctr"/>
-          <a:lstStyle/>
-          <a:p>
-            <a:pPr indent="0" marL="0">
-              <a:buNone/>
-            </a:pPr>
-            <a:r>
-              <a:rPr lang="en-US" sz="1600" dirty="0">
-                <a:solidFill>
-                  <a:srgbClr val="E8F1F2"/>
-                </a:solidFill>
-                <a:latin typeface="Calibri" pitchFamily="34" charset="0"/>
-                <a:ea typeface="Calibri" pitchFamily="34" charset="-122"/>
-                <a:cs typeface="Calibri" pitchFamily="34" charset="-120"/>
-              </a:rPr>
-              <a:t>Second vault cascades to V8</a:t>
-            </a:r>
-            <a:endParaRPr lang="en-US" sz="1600" dirty="0"/>
-          </a:p>
-        </p:txBody>
-      </p:sp>
-      <p:sp>
-        <p:nvSpPr>
-          <p:cNvPr id="29" name="Shape 27"/>
-          <p:cNvSpPr/>
-          <p:nvPr/>
-        </p:nvSpPr>
-        <p:spPr>
-          <a:xfrm>
-            <a:off x="8138160" y="3611880"/>
-            <a:ext cx="3611880" cy="2240280"/>
-          </a:xfrm>
-          <a:prstGeom prst="roundRect">
-            <a:avLst>
-              <a:gd name="adj" fmla="val 4082"/>
-            </a:avLst>
-          </a:prstGeom>
-          <a:solidFill>
-            <a:srgbClr val="0B2430"/>
-          </a:solidFill>
-          <a:ln/>
-        </p:spPr>
-      </p:sp>
-      <p:sp>
-        <p:nvSpPr>
-          <p:cNvPr id="30" name="Shape 28"/>
-          <p:cNvSpPr/>
-          <p:nvPr/>
-        </p:nvSpPr>
-        <p:spPr>
-          <a:xfrm>
-            <a:off x="8366760" y="3886200"/>
-            <a:ext cx="384048" cy="384048"/>
-          </a:xfrm>
-          <a:prstGeom prst="ellipse">
-            <a:avLst/>
-          </a:prstGeom>
-          <a:solidFill>
-            <a:srgbClr val="2EC4B6"/>
-          </a:solidFill>
-          <a:ln/>
-        </p:spPr>
-      </p:sp>
-      <p:sp>
-        <p:nvSpPr>
-          <p:cNvPr id="31" name="Text 29"/>
-          <p:cNvSpPr/>
-          <p:nvPr/>
-        </p:nvSpPr>
-        <p:spPr>
-          <a:xfrm>
-            <a:off x="8366760" y="3886200"/>
-            <a:ext cx="384048" cy="384048"/>
-          </a:xfrm>
-          <a:prstGeom prst="rect">
-            <a:avLst/>
-          </a:prstGeom>
-          <a:noFill/>
-          <a:ln/>
-        </p:spPr>
-        <p:txBody>
-          <a:bodyPr wrap="square" lIns="0" tIns="0" rIns="0" bIns="0" rtlCol="0" anchor="ctr"/>
-          <a:lstStyle/>
-          <a:p>
-            <a:pPr algn="ctr" indent="0" marL="0">
-              <a:buNone/>
-            </a:pPr>
-            <a:r>
-              <a:rPr lang="en-US" sz="1200" b="1" dirty="0">
-                <a:solidFill>
-                  <a:srgbClr val="04151C"/>
-                </a:solidFill>
-                <a:latin typeface="Calibri" pitchFamily="34" charset="0"/>
-                <a:ea typeface="Calibri" pitchFamily="34" charset="-122"/>
-                <a:cs typeface="Calibri" pitchFamily="34" charset="-120"/>
-              </a:rPr>
-              <a:t>6</a:t>
-            </a:r>
-            <a:endParaRPr lang="en-US" sz="1200" dirty="0"/>
-          </a:p>
-        </p:txBody>
-      </p:sp>
-      <p:sp>
-        <p:nvSpPr>
-          <p:cNvPr id="32" name="Text 30"/>
-          <p:cNvSpPr/>
-          <p:nvPr/>
-        </p:nvSpPr>
-        <p:spPr>
-          <a:xfrm>
-            <a:off x="8869680" y="3904488"/>
-            <a:ext cx="2560320" cy="365760"/>
-          </a:xfrm>
-          <a:prstGeom prst="rect">
-            <a:avLst/>
-          </a:prstGeom>
-          <a:noFill/>
-          <a:ln/>
-        </p:spPr>
-        <p:txBody>
-          <a:bodyPr wrap="square" lIns="0" tIns="0" rIns="0" bIns="0" rtlCol="0" anchor="ctr"/>
-          <a:lstStyle/>
-          <a:p>
-            <a:pPr indent="0" marL="0">
-              <a:buNone/>
-            </a:pPr>
-            <a:r>
-              <a:rPr lang="en-US" sz="1400" dirty="0">
-                <a:solidFill>
-                  <a:srgbClr val="2EC4B6"/>
-                </a:solidFill>
-                <a:latin typeface="Calibri" pitchFamily="34" charset="0"/>
-                <a:ea typeface="Calibri" pitchFamily="34" charset="-122"/>
-                <a:cs typeface="Calibri" pitchFamily="34" charset="-120"/>
-              </a:rPr>
-              <a:t>80–90s</a:t>
-            </a:r>
-            <a:endParaRPr lang="en-US" sz="1400" dirty="0"/>
-          </a:p>
-        </p:txBody>
-      </p:sp>
-      <p:sp>
-        <p:nvSpPr>
-          <p:cNvPr id="33" name="Text 31"/>
-          <p:cNvSpPr/>
-          <p:nvPr/>
-        </p:nvSpPr>
-        <p:spPr>
-          <a:xfrm>
-            <a:off x="8366760" y="4526280"/>
-            <a:ext cx="3154680" cy="1005840"/>
-          </a:xfrm>
-          <a:prstGeom prst="rect">
-            <a:avLst/>
-          </a:prstGeom>
-          <a:noFill/>
-          <a:ln/>
-        </p:spPr>
-        <p:txBody>
-          <a:bodyPr wrap="square" lIns="0" tIns="0" rIns="0" bIns="0" rtlCol="0" anchor="ctr"/>
-          <a:lstStyle/>
-          <a:p>
-            <a:pPr indent="0" marL="0">
-              <a:buNone/>
-            </a:pPr>
-            <a:r>
-              <a:rPr lang="en-US" sz="1600" dirty="0">
-                <a:solidFill>
-                  <a:srgbClr val="E8F1F2"/>
-                </a:solidFill>
-                <a:latin typeface="Calibri" pitchFamily="34" charset="0"/>
-                <a:ea typeface="Calibri" pitchFamily="34" charset="-122"/>
-                <a:cs typeface="Calibri" pitchFamily="34" charset="-120"/>
-              </a:rPr>
-              <a:t>Custody PDF + kWh hold vs move</a:t>
-            </a:r>
-            <a:endParaRPr lang="en-US" sz="1600" dirty="0"/>
           </a:p>
         </p:txBody>
       </p:sp>
@@ -5226,7 +4786,24 @@
                 <a:ea typeface="Calibri" pitchFamily="34" charset="-122"/>
                 <a:cs typeface="Calibri" pitchFamily="34" charset="-120"/>
               </a:rPr>
-              <a:t>Platelets 22±2°C   ·   FFP ≤ −30°C</a:t>
+              <a:t>Platelets 22±2°C, continuous agitation</a:t>
+            </a:r>
+            <a:endParaRPr lang="en-US" sz="1800" dirty="0"/>
+          </a:p>
+          <a:p>
+            <a:pPr indent="0" marL="0">
+              <a:buNone/>
+            </a:pPr>
+            <a:r>
+              <a:rPr lang="en-US" sz="1800" dirty="0">
+                <a:solidFill>
+                  <a:srgbClr val="E8F1F2"/>
+                </a:solidFill>
+                <a:latin typeface="Calibri" pitchFamily="34" charset="0"/>
+                <a:ea typeface="Calibri" pitchFamily="34" charset="-122"/>
+                <a:cs typeface="Calibri" pitchFamily="34" charset="-120"/>
+              </a:rPr>
+              <a:t>FFP ≤ −30°C</a:t>
             </a:r>
             <a:endParaRPr lang="en-US" sz="1800" dirty="0"/>
           </a:p>

</xml_diff>